<commit_message>
dev: create build specifications
</commit_message>
<xml_diff>
--- a/Buttons/Buttons.pptx
+++ b/Buttons/Buttons.pptx
@@ -261,7 +261,7 @@
           <a:p>
             <a:fld id="{7015E04F-913E-4DE9-9DBE-FF4774EA1521}" type="datetimeFigureOut">
               <a:rPr lang="en-GB" smtClean="0"/>
-              <a:t>29/06/2026</a:t>
+              <a:t>30/06/2026</a:t>
             </a:fld>
             <a:endParaRPr lang="en-GB"/>
           </a:p>
@@ -461,7 +461,7 @@
           <a:p>
             <a:fld id="{7015E04F-913E-4DE9-9DBE-FF4774EA1521}" type="datetimeFigureOut">
               <a:rPr lang="en-GB" smtClean="0"/>
-              <a:t>29/06/2026</a:t>
+              <a:t>30/06/2026</a:t>
             </a:fld>
             <a:endParaRPr lang="en-GB"/>
           </a:p>
@@ -671,7 +671,7 @@
           <a:p>
             <a:fld id="{7015E04F-913E-4DE9-9DBE-FF4774EA1521}" type="datetimeFigureOut">
               <a:rPr lang="en-GB" smtClean="0"/>
-              <a:t>29/06/2026</a:t>
+              <a:t>30/06/2026</a:t>
             </a:fld>
             <a:endParaRPr lang="en-GB"/>
           </a:p>
@@ -871,7 +871,7 @@
           <a:p>
             <a:fld id="{7015E04F-913E-4DE9-9DBE-FF4774EA1521}" type="datetimeFigureOut">
               <a:rPr lang="en-GB" smtClean="0"/>
-              <a:t>29/06/2026</a:t>
+              <a:t>30/06/2026</a:t>
             </a:fld>
             <a:endParaRPr lang="en-GB"/>
           </a:p>
@@ -1147,7 +1147,7 @@
           <a:p>
             <a:fld id="{7015E04F-913E-4DE9-9DBE-FF4774EA1521}" type="datetimeFigureOut">
               <a:rPr lang="en-GB" smtClean="0"/>
-              <a:t>29/06/2026</a:t>
+              <a:t>30/06/2026</a:t>
             </a:fld>
             <a:endParaRPr lang="en-GB"/>
           </a:p>
@@ -1415,7 +1415,7 @@
           <a:p>
             <a:fld id="{7015E04F-913E-4DE9-9DBE-FF4774EA1521}" type="datetimeFigureOut">
               <a:rPr lang="en-GB" smtClean="0"/>
-              <a:t>29/06/2026</a:t>
+              <a:t>30/06/2026</a:t>
             </a:fld>
             <a:endParaRPr lang="en-GB"/>
           </a:p>
@@ -1830,7 +1830,7 @@
           <a:p>
             <a:fld id="{7015E04F-913E-4DE9-9DBE-FF4774EA1521}" type="datetimeFigureOut">
               <a:rPr lang="en-GB" smtClean="0"/>
-              <a:t>29/06/2026</a:t>
+              <a:t>30/06/2026</a:t>
             </a:fld>
             <a:endParaRPr lang="en-GB"/>
           </a:p>
@@ -1972,7 +1972,7 @@
           <a:p>
             <a:fld id="{7015E04F-913E-4DE9-9DBE-FF4774EA1521}" type="datetimeFigureOut">
               <a:rPr lang="en-GB" smtClean="0"/>
-              <a:t>29/06/2026</a:t>
+              <a:t>30/06/2026</a:t>
             </a:fld>
             <a:endParaRPr lang="en-GB"/>
           </a:p>
@@ -2085,7 +2085,7 @@
           <a:p>
             <a:fld id="{7015E04F-913E-4DE9-9DBE-FF4774EA1521}" type="datetimeFigureOut">
               <a:rPr lang="en-GB" smtClean="0"/>
-              <a:t>29/06/2026</a:t>
+              <a:t>30/06/2026</a:t>
             </a:fld>
             <a:endParaRPr lang="en-GB"/>
           </a:p>
@@ -2398,7 +2398,7 @@
           <a:p>
             <a:fld id="{7015E04F-913E-4DE9-9DBE-FF4774EA1521}" type="datetimeFigureOut">
               <a:rPr lang="en-GB" smtClean="0"/>
-              <a:t>29/06/2026</a:t>
+              <a:t>30/06/2026</a:t>
             </a:fld>
             <a:endParaRPr lang="en-GB"/>
           </a:p>
@@ -2687,7 +2687,7 @@
           <a:p>
             <a:fld id="{7015E04F-913E-4DE9-9DBE-FF4774EA1521}" type="datetimeFigureOut">
               <a:rPr lang="en-GB" smtClean="0"/>
-              <a:t>29/06/2026</a:t>
+              <a:t>30/06/2026</a:t>
             </a:fld>
             <a:endParaRPr lang="en-GB"/>
           </a:p>
@@ -2930,7 +2930,7 @@
           <a:p>
             <a:fld id="{7015E04F-913E-4DE9-9DBE-FF4774EA1521}" type="datetimeFigureOut">
               <a:rPr lang="en-GB" smtClean="0"/>
-              <a:t>29/06/2026</a:t>
+              <a:t>30/06/2026</a:t>
             </a:fld>
             <a:endParaRPr lang="en-GB"/>
           </a:p>
@@ -3676,6 +3676,227 @@
           </a:p>
         </p:txBody>
       </p:sp>
+      <p:sp>
+        <p:nvSpPr>
+          <p:cNvPr id="3" name="Rectangle: Rounded Corners 2">
+            <a:extLst>
+              <a:ext uri="{FF2B5EF4-FFF2-40B4-BE49-F238E27FC236}">
+                <a16:creationId xmlns:a16="http://schemas.microsoft.com/office/drawing/2014/main" id="{473CEED6-44F5-B300-470F-C39C165B1973}"/>
+              </a:ext>
+            </a:extLst>
+          </p:cNvPr>
+          <p:cNvSpPr/>
+          <p:nvPr/>
+        </p:nvSpPr>
+        <p:spPr>
+          <a:xfrm>
+            <a:off x="3790259" y="1710354"/>
+            <a:ext cx="549588" cy="549588"/>
+          </a:xfrm>
+          <a:prstGeom prst="roundRect">
+            <a:avLst/>
+          </a:prstGeom>
+          <a:solidFill>
+            <a:schemeClr val="bg1"/>
+          </a:solidFill>
+        </p:spPr>
+        <p:style>
+          <a:lnRef idx="2">
+            <a:schemeClr val="accent1">
+              <a:shade val="15000"/>
+            </a:schemeClr>
+          </a:lnRef>
+          <a:fillRef idx="1">
+            <a:schemeClr val="accent1"/>
+          </a:fillRef>
+          <a:effectRef idx="0">
+            <a:schemeClr val="accent1"/>
+          </a:effectRef>
+          <a:fontRef idx="minor">
+            <a:schemeClr val="lt1"/>
+          </a:fontRef>
+        </p:style>
+        <p:txBody>
+          <a:bodyPr rtlCol="0" anchor="ctr"/>
+          <a:lstStyle/>
+          <a:p>
+            <a:pPr algn="ctr"/>
+            <a:endParaRPr lang="en-GB"/>
+          </a:p>
+        </p:txBody>
+      </p:sp>
+      <p:cxnSp>
+        <p:nvCxnSpPr>
+          <p:cNvPr id="8" name="Straight Connector 7">
+            <a:extLst>
+              <a:ext uri="{FF2B5EF4-FFF2-40B4-BE49-F238E27FC236}">
+                <a16:creationId xmlns:a16="http://schemas.microsoft.com/office/drawing/2014/main" id="{2EAFCDE1-2207-B629-7F46-467316EECB06}"/>
+              </a:ext>
+            </a:extLst>
+          </p:cNvPr>
+          <p:cNvCxnSpPr>
+            <a:cxnSpLocks/>
+          </p:cNvCxnSpPr>
+          <p:nvPr/>
+        </p:nvCxnSpPr>
+        <p:spPr>
+          <a:xfrm>
+            <a:off x="3970296" y="1710354"/>
+            <a:ext cx="0" cy="549588"/>
+          </a:xfrm>
+          <a:prstGeom prst="line">
+            <a:avLst/>
+          </a:prstGeom>
+          <a:ln>
+            <a:solidFill>
+              <a:schemeClr val="tx1"/>
+            </a:solidFill>
+          </a:ln>
+        </p:spPr>
+        <p:style>
+          <a:lnRef idx="2">
+            <a:schemeClr val="accent1"/>
+          </a:lnRef>
+          <a:fillRef idx="0">
+            <a:schemeClr val="accent1"/>
+          </a:fillRef>
+          <a:effectRef idx="1">
+            <a:schemeClr val="accent1"/>
+          </a:effectRef>
+          <a:fontRef idx="minor">
+            <a:schemeClr val="tx1"/>
+          </a:fontRef>
+        </p:style>
+      </p:cxnSp>
+      <p:cxnSp>
+        <p:nvCxnSpPr>
+          <p:cNvPr id="10" name="Straight Connector 9">
+            <a:extLst>
+              <a:ext uri="{FF2B5EF4-FFF2-40B4-BE49-F238E27FC236}">
+                <a16:creationId xmlns:a16="http://schemas.microsoft.com/office/drawing/2014/main" id="{1AC550C4-A852-6F1A-BA0F-A1B98429CDDD}"/>
+              </a:ext>
+            </a:extLst>
+          </p:cNvPr>
+          <p:cNvCxnSpPr>
+            <a:cxnSpLocks/>
+          </p:cNvCxnSpPr>
+          <p:nvPr/>
+        </p:nvCxnSpPr>
+        <p:spPr>
+          <a:xfrm>
+            <a:off x="4156651" y="1710354"/>
+            <a:ext cx="0" cy="549588"/>
+          </a:xfrm>
+          <a:prstGeom prst="line">
+            <a:avLst/>
+          </a:prstGeom>
+          <a:ln>
+            <a:solidFill>
+              <a:schemeClr val="tx1"/>
+            </a:solidFill>
+          </a:ln>
+        </p:spPr>
+        <p:style>
+          <a:lnRef idx="2">
+            <a:schemeClr val="accent1"/>
+          </a:lnRef>
+          <a:fillRef idx="0">
+            <a:schemeClr val="accent1"/>
+          </a:fillRef>
+          <a:effectRef idx="1">
+            <a:schemeClr val="accent1"/>
+          </a:effectRef>
+          <a:fontRef idx="minor">
+            <a:schemeClr val="tx1"/>
+          </a:fontRef>
+        </p:style>
+      </p:cxnSp>
+      <p:cxnSp>
+        <p:nvCxnSpPr>
+          <p:cNvPr id="13" name="Straight Connector 12">
+            <a:extLst>
+              <a:ext uri="{FF2B5EF4-FFF2-40B4-BE49-F238E27FC236}">
+                <a16:creationId xmlns:a16="http://schemas.microsoft.com/office/drawing/2014/main" id="{E1E258CE-833D-2564-2E9A-017029C413C3}"/>
+              </a:ext>
+            </a:extLst>
+          </p:cNvPr>
+          <p:cNvCxnSpPr>
+            <a:cxnSpLocks/>
+          </p:cNvCxnSpPr>
+          <p:nvPr/>
+        </p:nvCxnSpPr>
+        <p:spPr>
+          <a:xfrm rot="5400000">
+            <a:off x="4065053" y="1621126"/>
+            <a:ext cx="0" cy="549588"/>
+          </a:xfrm>
+          <a:prstGeom prst="line">
+            <a:avLst/>
+          </a:prstGeom>
+          <a:ln>
+            <a:solidFill>
+              <a:schemeClr val="tx1"/>
+            </a:solidFill>
+          </a:ln>
+        </p:spPr>
+        <p:style>
+          <a:lnRef idx="2">
+            <a:schemeClr val="accent1"/>
+          </a:lnRef>
+          <a:fillRef idx="0">
+            <a:schemeClr val="accent1"/>
+          </a:fillRef>
+          <a:effectRef idx="1">
+            <a:schemeClr val="accent1"/>
+          </a:effectRef>
+          <a:fontRef idx="minor">
+            <a:schemeClr val="tx1"/>
+          </a:fontRef>
+        </p:style>
+      </p:cxnSp>
+      <p:cxnSp>
+        <p:nvCxnSpPr>
+          <p:cNvPr id="15" name="Straight Connector 14">
+            <a:extLst>
+              <a:ext uri="{FF2B5EF4-FFF2-40B4-BE49-F238E27FC236}">
+                <a16:creationId xmlns:a16="http://schemas.microsoft.com/office/drawing/2014/main" id="{ABC475AF-2D93-49F2-1B85-A9045E99DAE1}"/>
+              </a:ext>
+            </a:extLst>
+          </p:cNvPr>
+          <p:cNvCxnSpPr>
+            <a:cxnSpLocks/>
+          </p:cNvCxnSpPr>
+          <p:nvPr/>
+        </p:nvCxnSpPr>
+        <p:spPr>
+          <a:xfrm rot="5400000">
+            <a:off x="4065053" y="1806296"/>
+            <a:ext cx="0" cy="549588"/>
+          </a:xfrm>
+          <a:prstGeom prst="line">
+            <a:avLst/>
+          </a:prstGeom>
+          <a:ln>
+            <a:solidFill>
+              <a:schemeClr val="tx1"/>
+            </a:solidFill>
+          </a:ln>
+        </p:spPr>
+        <p:style>
+          <a:lnRef idx="2">
+            <a:schemeClr val="accent1"/>
+          </a:lnRef>
+          <a:fillRef idx="0">
+            <a:schemeClr val="accent1"/>
+          </a:fillRef>
+          <a:effectRef idx="1">
+            <a:schemeClr val="accent1"/>
+          </a:effectRef>
+          <a:fontRef idx="minor">
+            <a:schemeClr val="tx1"/>
+          </a:fontRef>
+        </p:style>
+      </p:cxnSp>
     </p:spTree>
     <p:extLst>
       <p:ext uri="{BB962C8B-B14F-4D97-AF65-F5344CB8AC3E}">

</xml_diff>

<commit_message>
dev: update keyboard with colours
</commit_message>
<xml_diff>
--- a/Buttons/Buttons.pptx
+++ b/Buttons/Buttons.pptx
@@ -261,7 +261,7 @@
           <a:p>
             <a:fld id="{7015E04F-913E-4DE9-9DBE-FF4774EA1521}" type="datetimeFigureOut">
               <a:rPr lang="en-GB" smtClean="0"/>
-              <a:t>30/06/2026</a:t>
+              <a:t>01/07/2026</a:t>
             </a:fld>
             <a:endParaRPr lang="en-GB"/>
           </a:p>
@@ -461,7 +461,7 @@
           <a:p>
             <a:fld id="{7015E04F-913E-4DE9-9DBE-FF4774EA1521}" type="datetimeFigureOut">
               <a:rPr lang="en-GB" smtClean="0"/>
-              <a:t>30/06/2026</a:t>
+              <a:t>01/07/2026</a:t>
             </a:fld>
             <a:endParaRPr lang="en-GB"/>
           </a:p>
@@ -671,7 +671,7 @@
           <a:p>
             <a:fld id="{7015E04F-913E-4DE9-9DBE-FF4774EA1521}" type="datetimeFigureOut">
               <a:rPr lang="en-GB" smtClean="0"/>
-              <a:t>30/06/2026</a:t>
+              <a:t>01/07/2026</a:t>
             </a:fld>
             <a:endParaRPr lang="en-GB"/>
           </a:p>
@@ -871,7 +871,7 @@
           <a:p>
             <a:fld id="{7015E04F-913E-4DE9-9DBE-FF4774EA1521}" type="datetimeFigureOut">
               <a:rPr lang="en-GB" smtClean="0"/>
-              <a:t>30/06/2026</a:t>
+              <a:t>01/07/2026</a:t>
             </a:fld>
             <a:endParaRPr lang="en-GB"/>
           </a:p>
@@ -1147,7 +1147,7 @@
           <a:p>
             <a:fld id="{7015E04F-913E-4DE9-9DBE-FF4774EA1521}" type="datetimeFigureOut">
               <a:rPr lang="en-GB" smtClean="0"/>
-              <a:t>30/06/2026</a:t>
+              <a:t>01/07/2026</a:t>
             </a:fld>
             <a:endParaRPr lang="en-GB"/>
           </a:p>
@@ -1415,7 +1415,7 @@
           <a:p>
             <a:fld id="{7015E04F-913E-4DE9-9DBE-FF4774EA1521}" type="datetimeFigureOut">
               <a:rPr lang="en-GB" smtClean="0"/>
-              <a:t>30/06/2026</a:t>
+              <a:t>01/07/2026</a:t>
             </a:fld>
             <a:endParaRPr lang="en-GB"/>
           </a:p>
@@ -1830,7 +1830,7 @@
           <a:p>
             <a:fld id="{7015E04F-913E-4DE9-9DBE-FF4774EA1521}" type="datetimeFigureOut">
               <a:rPr lang="en-GB" smtClean="0"/>
-              <a:t>30/06/2026</a:t>
+              <a:t>01/07/2026</a:t>
             </a:fld>
             <a:endParaRPr lang="en-GB"/>
           </a:p>
@@ -1972,7 +1972,7 @@
           <a:p>
             <a:fld id="{7015E04F-913E-4DE9-9DBE-FF4774EA1521}" type="datetimeFigureOut">
               <a:rPr lang="en-GB" smtClean="0"/>
-              <a:t>30/06/2026</a:t>
+              <a:t>01/07/2026</a:t>
             </a:fld>
             <a:endParaRPr lang="en-GB"/>
           </a:p>
@@ -2085,7 +2085,7 @@
           <a:p>
             <a:fld id="{7015E04F-913E-4DE9-9DBE-FF4774EA1521}" type="datetimeFigureOut">
               <a:rPr lang="en-GB" smtClean="0"/>
-              <a:t>30/06/2026</a:t>
+              <a:t>01/07/2026</a:t>
             </a:fld>
             <a:endParaRPr lang="en-GB"/>
           </a:p>
@@ -2398,7 +2398,7 @@
           <a:p>
             <a:fld id="{7015E04F-913E-4DE9-9DBE-FF4774EA1521}" type="datetimeFigureOut">
               <a:rPr lang="en-GB" smtClean="0"/>
-              <a:t>30/06/2026</a:t>
+              <a:t>01/07/2026</a:t>
             </a:fld>
             <a:endParaRPr lang="en-GB"/>
           </a:p>
@@ -2687,7 +2687,7 @@
           <a:p>
             <a:fld id="{7015E04F-913E-4DE9-9DBE-FF4774EA1521}" type="datetimeFigureOut">
               <a:rPr lang="en-GB" smtClean="0"/>
-              <a:t>30/06/2026</a:t>
+              <a:t>01/07/2026</a:t>
             </a:fld>
             <a:endParaRPr lang="en-GB"/>
           </a:p>
@@ -2930,7 +2930,7 @@
           <a:p>
             <a:fld id="{7015E04F-913E-4DE9-9DBE-FF4774EA1521}" type="datetimeFigureOut">
               <a:rPr lang="en-GB" smtClean="0"/>
-              <a:t>30/06/2026</a:t>
+              <a:t>01/07/2026</a:t>
             </a:fld>
             <a:endParaRPr lang="en-GB"/>
           </a:p>
@@ -3423,11 +3423,7 @@
           <a:prstGeom prst="roundRect">
             <a:avLst/>
           </a:prstGeom>
-          <a:solidFill>
-            <a:schemeClr val="bg1">
-              <a:lumMod val="50000"/>
-            </a:schemeClr>
-          </a:solidFill>
+          <a:noFill/>
           <a:ln w="6350">
             <a:solidFill>
               <a:schemeClr val="tx1"/>
@@ -3676,227 +3672,476 @@
           </a:p>
         </p:txBody>
       </p:sp>
-      <p:sp>
-        <p:nvSpPr>
-          <p:cNvPr id="3" name="Rectangle: Rounded Corners 2">
-            <a:extLst>
-              <a:ext uri="{FF2B5EF4-FFF2-40B4-BE49-F238E27FC236}">
-                <a16:creationId xmlns:a16="http://schemas.microsoft.com/office/drawing/2014/main" id="{473CEED6-44F5-B300-470F-C39C165B1973}"/>
-              </a:ext>
-            </a:extLst>
-          </p:cNvPr>
-          <p:cNvSpPr/>
+      <p:pic>
+        <p:nvPicPr>
+          <p:cNvPr id="27" name="Picture 26">
+            <a:extLst>
+              <a:ext uri="{FF2B5EF4-FFF2-40B4-BE49-F238E27FC236}">
+                <a16:creationId xmlns:a16="http://schemas.microsoft.com/office/drawing/2014/main" id="{778CE399-56B4-78BC-3CBB-308AC854460D}"/>
+              </a:ext>
+            </a:extLst>
+          </p:cNvPr>
+          <p:cNvPicPr>
+            <a:picLocks noChangeAspect="1"/>
+          </p:cNvPicPr>
           <p:nvPr/>
-        </p:nvSpPr>
+        </p:nvPicPr>
+        <p:blipFill>
+          <a:blip r:embed="rId3"/>
+          <a:srcRect l="19145" t="34103"/>
+          <a:stretch>
+            <a:fillRect/>
+          </a:stretch>
+        </p:blipFill>
         <p:spPr>
           <a:xfrm>
-            <a:off x="3790259" y="1710354"/>
-            <a:ext cx="549588" cy="549588"/>
+            <a:off x="3686026" y="2776366"/>
+            <a:ext cx="6315223" cy="2705271"/>
           </a:xfrm>
-          <a:prstGeom prst="roundRect">
+          <a:prstGeom prst="rect">
             <a:avLst/>
           </a:prstGeom>
-          <a:solidFill>
-            <a:schemeClr val="bg1"/>
-          </a:solidFill>
         </p:spPr>
-        <p:style>
-          <a:lnRef idx="2">
-            <a:schemeClr val="accent1">
-              <a:shade val="15000"/>
-            </a:schemeClr>
-          </a:lnRef>
-          <a:fillRef idx="1">
-            <a:schemeClr val="accent1"/>
-          </a:fillRef>
-          <a:effectRef idx="0">
-            <a:schemeClr val="accent1"/>
-          </a:effectRef>
-          <a:fontRef idx="minor">
-            <a:schemeClr val="lt1"/>
-          </a:fontRef>
-        </p:style>
-        <p:txBody>
-          <a:bodyPr rtlCol="0" anchor="ctr"/>
-          <a:lstStyle/>
-          <a:p>
-            <a:pPr algn="ctr"/>
-            <a:endParaRPr lang="en-GB"/>
-          </a:p>
-        </p:txBody>
-      </p:sp>
-      <p:cxnSp>
-        <p:nvCxnSpPr>
-          <p:cNvPr id="8" name="Straight Connector 7">
-            <a:extLst>
-              <a:ext uri="{FF2B5EF4-FFF2-40B4-BE49-F238E27FC236}">
-                <a16:creationId xmlns:a16="http://schemas.microsoft.com/office/drawing/2014/main" id="{2EAFCDE1-2207-B629-7F46-467316EECB06}"/>
-              </a:ext>
-            </a:extLst>
-          </p:cNvPr>
-          <p:cNvCxnSpPr>
-            <a:cxnSpLocks/>
-          </p:cNvCxnSpPr>
+      </p:pic>
+      <p:grpSp>
+        <p:nvGrpSpPr>
+          <p:cNvPr id="37" name="Group 36">
+            <a:extLst>
+              <a:ext uri="{FF2B5EF4-FFF2-40B4-BE49-F238E27FC236}">
+                <a16:creationId xmlns:a16="http://schemas.microsoft.com/office/drawing/2014/main" id="{AC0FFEE6-6950-8FA4-00CF-31660C414C3D}"/>
+              </a:ext>
+            </a:extLst>
+          </p:cNvPr>
+          <p:cNvGrpSpPr/>
           <p:nvPr/>
-        </p:nvCxnSpPr>
+        </p:nvGrpSpPr>
+        <p:grpSpPr>
+          <a:xfrm>
+            <a:off x="3866064" y="1710649"/>
+            <a:ext cx="566977" cy="556342"/>
+            <a:chOff x="3780783" y="1703600"/>
+            <a:chExt cx="566977" cy="556342"/>
+          </a:xfrm>
+        </p:grpSpPr>
+        <p:grpSp>
+          <p:nvGrpSpPr>
+            <p:cNvPr id="16" name="Group 15">
+              <a:extLst>
+                <a:ext uri="{FF2B5EF4-FFF2-40B4-BE49-F238E27FC236}">
+                  <a16:creationId xmlns:a16="http://schemas.microsoft.com/office/drawing/2014/main" id="{F51B0178-D523-FE75-1D44-82B0EC123D38}"/>
+                </a:ext>
+              </a:extLst>
+            </p:cNvPr>
+            <p:cNvGrpSpPr/>
+            <p:nvPr/>
+          </p:nvGrpSpPr>
+          <p:grpSpPr>
+            <a:xfrm>
+              <a:off x="3790259" y="1710354"/>
+              <a:ext cx="549588" cy="549588"/>
+              <a:chOff x="3790259" y="1710354"/>
+              <a:chExt cx="549588" cy="549588"/>
+            </a:xfrm>
+          </p:grpSpPr>
+          <p:sp>
+            <p:nvSpPr>
+              <p:cNvPr id="3" name="Rectangle: Rounded Corners 2">
+                <a:extLst>
+                  <a:ext uri="{FF2B5EF4-FFF2-40B4-BE49-F238E27FC236}">
+                    <a16:creationId xmlns:a16="http://schemas.microsoft.com/office/drawing/2014/main" id="{473CEED6-44F5-B300-470F-C39C165B1973}"/>
+                  </a:ext>
+                </a:extLst>
+              </p:cNvPr>
+              <p:cNvSpPr/>
+              <p:nvPr/>
+            </p:nvSpPr>
+            <p:spPr>
+              <a:xfrm>
+                <a:off x="3790259" y="1710354"/>
+                <a:ext cx="549588" cy="549588"/>
+              </a:xfrm>
+              <a:prstGeom prst="roundRect">
+                <a:avLst/>
+              </a:prstGeom>
+              <a:solidFill>
+                <a:srgbClr val="7CB677"/>
+              </a:solidFill>
+            </p:spPr>
+            <p:style>
+              <a:lnRef idx="2">
+                <a:schemeClr val="accent1">
+                  <a:shade val="15000"/>
+                </a:schemeClr>
+              </a:lnRef>
+              <a:fillRef idx="1">
+                <a:schemeClr val="accent1"/>
+              </a:fillRef>
+              <a:effectRef idx="0">
+                <a:schemeClr val="accent1"/>
+              </a:effectRef>
+              <a:fontRef idx="minor">
+                <a:schemeClr val="lt1"/>
+              </a:fontRef>
+            </p:style>
+            <p:txBody>
+              <a:bodyPr rtlCol="0" anchor="ctr"/>
+              <a:lstStyle/>
+              <a:p>
+                <a:pPr algn="ctr"/>
+                <a:endParaRPr lang="en-GB"/>
+              </a:p>
+            </p:txBody>
+          </p:sp>
+          <p:cxnSp>
+            <p:nvCxnSpPr>
+              <p:cNvPr id="8" name="Straight Connector 7">
+                <a:extLst>
+                  <a:ext uri="{FF2B5EF4-FFF2-40B4-BE49-F238E27FC236}">
+                    <a16:creationId xmlns:a16="http://schemas.microsoft.com/office/drawing/2014/main" id="{2EAFCDE1-2207-B629-7F46-467316EECB06}"/>
+                  </a:ext>
+                </a:extLst>
+              </p:cNvPr>
+              <p:cNvCxnSpPr>
+                <a:cxnSpLocks/>
+              </p:cNvCxnSpPr>
+              <p:nvPr/>
+            </p:nvCxnSpPr>
+            <p:spPr>
+              <a:xfrm>
+                <a:off x="3970296" y="1710354"/>
+                <a:ext cx="0" cy="549588"/>
+              </a:xfrm>
+              <a:prstGeom prst="line">
+                <a:avLst/>
+              </a:prstGeom>
+              <a:ln>
+                <a:solidFill>
+                  <a:schemeClr val="tx1"/>
+                </a:solidFill>
+              </a:ln>
+            </p:spPr>
+            <p:style>
+              <a:lnRef idx="2">
+                <a:schemeClr val="accent1"/>
+              </a:lnRef>
+              <a:fillRef idx="0">
+                <a:schemeClr val="accent1"/>
+              </a:fillRef>
+              <a:effectRef idx="1">
+                <a:schemeClr val="accent1"/>
+              </a:effectRef>
+              <a:fontRef idx="minor">
+                <a:schemeClr val="tx1"/>
+              </a:fontRef>
+            </p:style>
+          </p:cxnSp>
+          <p:cxnSp>
+            <p:nvCxnSpPr>
+              <p:cNvPr id="10" name="Straight Connector 9">
+                <a:extLst>
+                  <a:ext uri="{FF2B5EF4-FFF2-40B4-BE49-F238E27FC236}">
+                    <a16:creationId xmlns:a16="http://schemas.microsoft.com/office/drawing/2014/main" id="{1AC550C4-A852-6F1A-BA0F-A1B98429CDDD}"/>
+                  </a:ext>
+                </a:extLst>
+              </p:cNvPr>
+              <p:cNvCxnSpPr>
+                <a:cxnSpLocks/>
+              </p:cNvCxnSpPr>
+              <p:nvPr/>
+            </p:nvCxnSpPr>
+            <p:spPr>
+              <a:xfrm>
+                <a:off x="4156651" y="1710354"/>
+                <a:ext cx="0" cy="549588"/>
+              </a:xfrm>
+              <a:prstGeom prst="line">
+                <a:avLst/>
+              </a:prstGeom>
+              <a:ln>
+                <a:solidFill>
+                  <a:schemeClr val="tx1"/>
+                </a:solidFill>
+              </a:ln>
+            </p:spPr>
+            <p:style>
+              <a:lnRef idx="2">
+                <a:schemeClr val="accent1"/>
+              </a:lnRef>
+              <a:fillRef idx="0">
+                <a:schemeClr val="accent1"/>
+              </a:fillRef>
+              <a:effectRef idx="1">
+                <a:schemeClr val="accent1"/>
+              </a:effectRef>
+              <a:fontRef idx="minor">
+                <a:schemeClr val="tx1"/>
+              </a:fontRef>
+            </p:style>
+          </p:cxnSp>
+          <p:cxnSp>
+            <p:nvCxnSpPr>
+              <p:cNvPr id="13" name="Straight Connector 12">
+                <a:extLst>
+                  <a:ext uri="{FF2B5EF4-FFF2-40B4-BE49-F238E27FC236}">
+                    <a16:creationId xmlns:a16="http://schemas.microsoft.com/office/drawing/2014/main" id="{E1E258CE-833D-2564-2E9A-017029C413C3}"/>
+                  </a:ext>
+                </a:extLst>
+              </p:cNvPr>
+              <p:cNvCxnSpPr>
+                <a:cxnSpLocks/>
+              </p:cNvCxnSpPr>
+              <p:nvPr/>
+            </p:nvCxnSpPr>
+            <p:spPr>
+              <a:xfrm rot="5400000">
+                <a:off x="4065053" y="1621126"/>
+                <a:ext cx="0" cy="549588"/>
+              </a:xfrm>
+              <a:prstGeom prst="line">
+                <a:avLst/>
+              </a:prstGeom>
+              <a:ln>
+                <a:solidFill>
+                  <a:schemeClr val="tx1"/>
+                </a:solidFill>
+              </a:ln>
+            </p:spPr>
+            <p:style>
+              <a:lnRef idx="2">
+                <a:schemeClr val="accent1"/>
+              </a:lnRef>
+              <a:fillRef idx="0">
+                <a:schemeClr val="accent1"/>
+              </a:fillRef>
+              <a:effectRef idx="1">
+                <a:schemeClr val="accent1"/>
+              </a:effectRef>
+              <a:fontRef idx="minor">
+                <a:schemeClr val="tx1"/>
+              </a:fontRef>
+            </p:style>
+          </p:cxnSp>
+          <p:cxnSp>
+            <p:nvCxnSpPr>
+              <p:cNvPr id="15" name="Straight Connector 14">
+                <a:extLst>
+                  <a:ext uri="{FF2B5EF4-FFF2-40B4-BE49-F238E27FC236}">
+                    <a16:creationId xmlns:a16="http://schemas.microsoft.com/office/drawing/2014/main" id="{ABC475AF-2D93-49F2-1B85-A9045E99DAE1}"/>
+                  </a:ext>
+                </a:extLst>
+              </p:cNvPr>
+              <p:cNvCxnSpPr>
+                <a:cxnSpLocks/>
+              </p:cNvCxnSpPr>
+              <p:nvPr/>
+            </p:nvCxnSpPr>
+            <p:spPr>
+              <a:xfrm rot="5400000">
+                <a:off x="4065053" y="1806296"/>
+                <a:ext cx="0" cy="549588"/>
+              </a:xfrm>
+              <a:prstGeom prst="line">
+                <a:avLst/>
+              </a:prstGeom>
+              <a:ln>
+                <a:solidFill>
+                  <a:schemeClr val="tx1"/>
+                </a:solidFill>
+              </a:ln>
+            </p:spPr>
+            <p:style>
+              <a:lnRef idx="2">
+                <a:schemeClr val="accent1"/>
+              </a:lnRef>
+              <a:fillRef idx="0">
+                <a:schemeClr val="accent1"/>
+              </a:fillRef>
+              <a:effectRef idx="1">
+                <a:schemeClr val="accent1"/>
+              </a:effectRef>
+              <a:fontRef idx="minor">
+                <a:schemeClr val="tx1"/>
+              </a:fontRef>
+            </p:style>
+          </p:cxnSp>
+        </p:grpSp>
+        <p:sp>
+          <p:nvSpPr>
+            <p:cNvPr id="17" name="Rectangle 16">
+              <a:extLst>
+                <a:ext uri="{FF2B5EF4-FFF2-40B4-BE49-F238E27FC236}">
+                  <a16:creationId xmlns:a16="http://schemas.microsoft.com/office/drawing/2014/main" id="{647EA39F-FB1A-F58F-DD73-D273152658BC}"/>
+                </a:ext>
+              </a:extLst>
+            </p:cNvPr>
+            <p:cNvSpPr/>
+            <p:nvPr/>
+          </p:nvSpPr>
+          <p:spPr>
+            <a:xfrm>
+              <a:off x="3969730" y="1895919"/>
+              <a:ext cx="185163" cy="185163"/>
+            </a:xfrm>
+            <a:prstGeom prst="rect">
+              <a:avLst/>
+            </a:prstGeom>
+            <a:solidFill>
+              <a:srgbClr val="DBBC45"/>
+            </a:solidFill>
+          </p:spPr>
+          <p:style>
+            <a:lnRef idx="2">
+              <a:schemeClr val="accent1">
+                <a:shade val="15000"/>
+              </a:schemeClr>
+            </a:lnRef>
+            <a:fillRef idx="1">
+              <a:schemeClr val="accent1"/>
+            </a:fillRef>
+            <a:effectRef idx="0">
+              <a:schemeClr val="accent1"/>
+            </a:effectRef>
+            <a:fontRef idx="minor">
+              <a:schemeClr val="lt1"/>
+            </a:fontRef>
+          </p:style>
+          <p:txBody>
+            <a:bodyPr rtlCol="0" anchor="ctr"/>
+            <a:lstStyle/>
+            <a:p>
+              <a:pPr algn="ctr"/>
+              <a:endParaRPr lang="en-GB" dirty="0"/>
+            </a:p>
+          </p:txBody>
+        </p:sp>
+        <p:pic>
+          <p:nvPicPr>
+            <p:cNvPr id="35" name="Picture 34">
+              <a:extLst>
+                <a:ext uri="{FF2B5EF4-FFF2-40B4-BE49-F238E27FC236}">
+                  <a16:creationId xmlns:a16="http://schemas.microsoft.com/office/drawing/2014/main" id="{4D771464-DAB3-6344-4AF6-A7B7EB3DE88D}"/>
+                </a:ext>
+              </a:extLst>
+            </p:cNvPr>
+            <p:cNvPicPr>
+              <a:picLocks noChangeAspect="1"/>
+            </p:cNvPicPr>
+            <p:nvPr/>
+          </p:nvPicPr>
+          <p:blipFill>
+            <a:blip r:embed="rId4"/>
+            <a:srcRect b="65571"/>
+            <a:stretch>
+              <a:fillRect/>
+            </a:stretch>
+          </p:blipFill>
+          <p:spPr>
+            <a:xfrm>
+              <a:off x="3780783" y="1703600"/>
+              <a:ext cx="566977" cy="197307"/>
+            </a:xfrm>
+            <a:prstGeom prst="rect">
+              <a:avLst/>
+            </a:prstGeom>
+          </p:spPr>
+        </p:pic>
+        <p:sp>
+          <p:nvSpPr>
+            <p:cNvPr id="36" name="Rectangle 35">
+              <a:extLst>
+                <a:ext uri="{FF2B5EF4-FFF2-40B4-BE49-F238E27FC236}">
+                  <a16:creationId xmlns:a16="http://schemas.microsoft.com/office/drawing/2014/main" id="{D67FB7DB-09CE-7F05-3FC6-04E962F67C07}"/>
+                </a:ext>
+              </a:extLst>
+            </p:cNvPr>
+            <p:cNvSpPr/>
+            <p:nvPr/>
+          </p:nvSpPr>
+          <p:spPr>
+            <a:xfrm>
+              <a:off x="3792151" y="1895919"/>
+              <a:ext cx="177579" cy="185163"/>
+            </a:xfrm>
+            <a:prstGeom prst="rect">
+              <a:avLst/>
+            </a:prstGeom>
+            <a:solidFill>
+              <a:schemeClr val="bg1"/>
+            </a:solidFill>
+          </p:spPr>
+          <p:style>
+            <a:lnRef idx="2">
+              <a:schemeClr val="accent1">
+                <a:shade val="15000"/>
+              </a:schemeClr>
+            </a:lnRef>
+            <a:fillRef idx="1">
+              <a:schemeClr val="accent1"/>
+            </a:fillRef>
+            <a:effectRef idx="0">
+              <a:schemeClr val="accent1"/>
+            </a:effectRef>
+            <a:fontRef idx="minor">
+              <a:schemeClr val="lt1"/>
+            </a:fontRef>
+          </p:style>
+          <p:txBody>
+            <a:bodyPr rtlCol="0" anchor="ctr"/>
+            <a:lstStyle/>
+            <a:p>
+              <a:pPr algn="ctr"/>
+              <a:endParaRPr lang="en-GB"/>
+            </a:p>
+          </p:txBody>
+        </p:sp>
+      </p:grpSp>
+      <p:sp>
+        <p:nvSpPr>
+          <p:cNvPr id="7" name="TextBox 6">
+            <a:extLst>
+              <a:ext uri="{FF2B5EF4-FFF2-40B4-BE49-F238E27FC236}">
+                <a16:creationId xmlns:a16="http://schemas.microsoft.com/office/drawing/2014/main" id="{085EE127-4568-546D-924E-C97E729F1B7F}"/>
+              </a:ext>
+            </a:extLst>
+          </p:cNvPr>
+          <p:cNvSpPr txBox="1"/>
+          <p:nvPr/>
+        </p:nvSpPr>
         <p:spPr>
           <a:xfrm>
-            <a:off x="3970296" y="1710354"/>
-            <a:ext cx="0" cy="549588"/>
+            <a:off x="2603187" y="744530"/>
+            <a:ext cx="2081083" cy="923330"/>
           </a:xfrm>
-          <a:prstGeom prst="line">
+          <a:prstGeom prst="rect">
             <a:avLst/>
           </a:prstGeom>
-          <a:ln>
-            <a:solidFill>
-              <a:schemeClr val="tx1"/>
-            </a:solidFill>
-          </a:ln>
+          <a:noFill/>
         </p:spPr>
-        <p:style>
-          <a:lnRef idx="2">
-            <a:schemeClr val="accent1"/>
-          </a:lnRef>
-          <a:fillRef idx="0">
-            <a:schemeClr val="accent1"/>
-          </a:fillRef>
-          <a:effectRef idx="1">
-            <a:schemeClr val="accent1"/>
-          </a:effectRef>
-          <a:fontRef idx="minor">
-            <a:schemeClr val="tx1"/>
-          </a:fontRef>
-        </p:style>
-      </p:cxnSp>
-      <p:cxnSp>
-        <p:nvCxnSpPr>
-          <p:cNvPr id="10" name="Straight Connector 9">
-            <a:extLst>
-              <a:ext uri="{FF2B5EF4-FFF2-40B4-BE49-F238E27FC236}">
-                <a16:creationId xmlns:a16="http://schemas.microsoft.com/office/drawing/2014/main" id="{1AC550C4-A852-6F1A-BA0F-A1B98429CDDD}"/>
-              </a:ext>
-            </a:extLst>
-          </p:cNvPr>
-          <p:cNvCxnSpPr>
-            <a:cxnSpLocks/>
-          </p:cNvCxnSpPr>
-          <p:nvPr/>
-        </p:nvCxnSpPr>
-        <p:spPr>
-          <a:xfrm>
-            <a:off x="4156651" y="1710354"/>
-            <a:ext cx="0" cy="549588"/>
-          </a:xfrm>
-          <a:prstGeom prst="line">
-            <a:avLst/>
-          </a:prstGeom>
-          <a:ln>
-            <a:solidFill>
-              <a:schemeClr val="tx1"/>
-            </a:solidFill>
-          </a:ln>
-        </p:spPr>
-        <p:style>
-          <a:lnRef idx="2">
-            <a:schemeClr val="accent1"/>
-          </a:lnRef>
-          <a:fillRef idx="0">
-            <a:schemeClr val="accent1"/>
-          </a:fillRef>
-          <a:effectRef idx="1">
-            <a:schemeClr val="accent1"/>
-          </a:effectRef>
-          <a:fontRef idx="minor">
-            <a:schemeClr val="tx1"/>
-          </a:fontRef>
-        </p:style>
-      </p:cxnSp>
-      <p:cxnSp>
-        <p:nvCxnSpPr>
-          <p:cNvPr id="13" name="Straight Connector 12">
-            <a:extLst>
-              <a:ext uri="{FF2B5EF4-FFF2-40B4-BE49-F238E27FC236}">
-                <a16:creationId xmlns:a16="http://schemas.microsoft.com/office/drawing/2014/main" id="{E1E258CE-833D-2564-2E9A-017029C413C3}"/>
-              </a:ext>
-            </a:extLst>
-          </p:cNvPr>
-          <p:cNvCxnSpPr>
-            <a:cxnSpLocks/>
-          </p:cNvCxnSpPr>
-          <p:nvPr/>
-        </p:nvCxnSpPr>
-        <p:spPr>
-          <a:xfrm rot="5400000">
-            <a:off x="4065053" y="1621126"/>
-            <a:ext cx="0" cy="549588"/>
-          </a:xfrm>
-          <a:prstGeom prst="line">
-            <a:avLst/>
-          </a:prstGeom>
-          <a:ln>
-            <a:solidFill>
-              <a:schemeClr val="tx1"/>
-            </a:solidFill>
-          </a:ln>
-        </p:spPr>
-        <p:style>
-          <a:lnRef idx="2">
-            <a:schemeClr val="accent1"/>
-          </a:lnRef>
-          <a:fillRef idx="0">
-            <a:schemeClr val="accent1"/>
-          </a:fillRef>
-          <a:effectRef idx="1">
-            <a:schemeClr val="accent1"/>
-          </a:effectRef>
-          <a:fontRef idx="minor">
-            <a:schemeClr val="tx1"/>
-          </a:fontRef>
-        </p:style>
-      </p:cxnSp>
-      <p:cxnSp>
-        <p:nvCxnSpPr>
-          <p:cNvPr id="15" name="Straight Connector 14">
-            <a:extLst>
-              <a:ext uri="{FF2B5EF4-FFF2-40B4-BE49-F238E27FC236}">
-                <a16:creationId xmlns:a16="http://schemas.microsoft.com/office/drawing/2014/main" id="{ABC475AF-2D93-49F2-1B85-A9045E99DAE1}"/>
-              </a:ext>
-            </a:extLst>
-          </p:cNvPr>
-          <p:cNvCxnSpPr>
-            <a:cxnSpLocks/>
-          </p:cNvCxnSpPr>
-          <p:nvPr/>
-        </p:nvCxnSpPr>
-        <p:spPr>
-          <a:xfrm rot="5400000">
-            <a:off x="4065053" y="1806296"/>
-            <a:ext cx="0" cy="549588"/>
-          </a:xfrm>
-          <a:prstGeom prst="line">
-            <a:avLst/>
-          </a:prstGeom>
-          <a:ln>
-            <a:solidFill>
-              <a:schemeClr val="tx1"/>
-            </a:solidFill>
-          </a:ln>
-        </p:spPr>
-        <p:style>
-          <a:lnRef idx="2">
-            <a:schemeClr val="accent1"/>
-          </a:lnRef>
-          <a:fillRef idx="0">
-            <a:schemeClr val="accent1"/>
-          </a:fillRef>
-          <a:effectRef idx="1">
-            <a:schemeClr val="accent1"/>
-          </a:effectRef>
-          <a:fontRef idx="minor">
-            <a:schemeClr val="tx1"/>
-          </a:fontRef>
-        </p:style>
-      </p:cxnSp>
+        <p:txBody>
+          <a:bodyPr wrap="none" rtlCol="0">
+            <a:spAutoFit/>
+          </a:bodyPr>
+          <a:lstStyle/>
+          <a:p>
+            <a:r>
+              <a:rPr lang="en-GB" dirty="0"/>
+              <a:t>219,188,69 Yellow</a:t>
+            </a:r>
+          </a:p>
+          <a:p>
+            <a:r>
+              <a:rPr lang="en-GB" dirty="0"/>
+              <a:t>124,182,119 Green</a:t>
+            </a:r>
+          </a:p>
+          <a:p>
+            <a:r>
+              <a:rPr lang="en-GB" dirty="0"/>
+              <a:t>120,124,126 Grey</a:t>
+            </a:r>
+          </a:p>
+        </p:txBody>
+      </p:sp>
     </p:spTree>
     <p:extLst>
       <p:ext uri="{BB962C8B-B14F-4D97-AF65-F5344CB8AC3E}">

</xml_diff>